<commit_message>
Alternations due to name change
</commit_message>
<xml_diff>
--- a/Model Slide RODeO.pptx
+++ b/Model Slide RODeO.pptx
@@ -218,7 +218,7 @@
           <a:p>
             <a:fld id="{DE45BC25-7985-425F-9FBB-3C38CB2116A1}" type="datetimeFigureOut">
               <a:rPr lang="en-US" smtClean="0"/>
-              <a:t>8/4/2020</a:t>
+              <a:t>6/1/2026</a:t>
             </a:fld>
             <a:endParaRPr lang="en-US"/>
           </a:p>
@@ -665,7 +665,7 @@
             <a:fld id="{1D8BD707-D9CF-40AE-B4C6-C98DA3205C09}" type="datetimeFigureOut">
               <a:rPr lang="en-US" smtClean="0"/>
               <a:pPr/>
-              <a:t>8/4/2020</a:t>
+              <a:t>6/1/2026</a:t>
             </a:fld>
             <a:endParaRPr lang="en-US"/>
           </a:p>
@@ -830,7 +830,7 @@
             <a:fld id="{1D8BD707-D9CF-40AE-B4C6-C98DA3205C09}" type="datetimeFigureOut">
               <a:rPr lang="en-US" smtClean="0"/>
               <a:pPr/>
-              <a:t>8/4/2020</a:t>
+              <a:t>6/1/2026</a:t>
             </a:fld>
             <a:endParaRPr lang="en-US"/>
           </a:p>
@@ -1005,7 +1005,7 @@
             <a:fld id="{1D8BD707-D9CF-40AE-B4C6-C98DA3205C09}" type="datetimeFigureOut">
               <a:rPr lang="en-US" smtClean="0"/>
               <a:pPr/>
-              <a:t>8/4/2020</a:t>
+              <a:t>6/1/2026</a:t>
             </a:fld>
             <a:endParaRPr lang="en-US"/>
           </a:p>
@@ -1253,7 +1253,7 @@
                 </a:solidFill>
               </a:rPr>
               <a:pPr/>
-              <a:t>8/4/2020</a:t>
+              <a:t>6/1/2026</a:t>
             </a:fld>
             <a:endParaRPr lang="en-US">
               <a:solidFill>
@@ -1467,7 +1467,7 @@
                 </a:solidFill>
               </a:rPr>
               <a:pPr/>
-              <a:t>8/4/2020</a:t>
+              <a:t>6/1/2026</a:t>
             </a:fld>
             <a:endParaRPr lang="en-US">
               <a:solidFill>
@@ -1747,7 +1747,7 @@
                 </a:solidFill>
               </a:rPr>
               <a:pPr/>
-              <a:t>8/4/2020</a:t>
+              <a:t>6/1/2026</a:t>
             </a:fld>
             <a:endParaRPr lang="en-US">
               <a:solidFill>
@@ -2067,7 +2067,7 @@
                 </a:solidFill>
               </a:rPr>
               <a:pPr/>
-              <a:t>8/4/2020</a:t>
+              <a:t>6/1/2026</a:t>
             </a:fld>
             <a:endParaRPr lang="en-US">
               <a:solidFill>
@@ -2521,7 +2521,7 @@
                 </a:solidFill>
               </a:rPr>
               <a:pPr/>
-              <a:t>8/4/2020</a:t>
+              <a:t>6/1/2026</a:t>
             </a:fld>
             <a:endParaRPr lang="en-US">
               <a:solidFill>
@@ -2673,7 +2673,7 @@
                 </a:solidFill>
               </a:rPr>
               <a:pPr/>
-              <a:t>8/4/2020</a:t>
+              <a:t>6/1/2026</a:t>
             </a:fld>
             <a:endParaRPr lang="en-US">
               <a:solidFill>
@@ -2803,7 +2803,7 @@
                 </a:solidFill>
               </a:rPr>
               <a:pPr/>
-              <a:t>8/4/2020</a:t>
+              <a:t>6/1/2026</a:t>
             </a:fld>
             <a:endParaRPr lang="en-US">
               <a:solidFill>
@@ -3113,7 +3113,7 @@
                 </a:solidFill>
               </a:rPr>
               <a:pPr/>
-              <a:t>8/4/2020</a:t>
+              <a:t>6/1/2026</a:t>
             </a:fld>
             <a:endParaRPr lang="en-US">
               <a:solidFill>
@@ -3310,7 +3310,7 @@
             <a:fld id="{1D8BD707-D9CF-40AE-B4C6-C98DA3205C09}" type="datetimeFigureOut">
               <a:rPr lang="en-US" smtClean="0"/>
               <a:pPr/>
-              <a:t>8/4/2020</a:t>
+              <a:t>6/1/2026</a:t>
             </a:fld>
             <a:endParaRPr lang="en-US"/>
           </a:p>
@@ -3568,7 +3568,7 @@
                 </a:solidFill>
               </a:rPr>
               <a:pPr/>
-              <a:t>8/4/2020</a:t>
+              <a:t>6/1/2026</a:t>
             </a:fld>
             <a:endParaRPr lang="en-US">
               <a:solidFill>
@@ -3771,7 +3771,7 @@
                 </a:solidFill>
               </a:rPr>
               <a:pPr/>
-              <a:t>8/4/2020</a:t>
+              <a:t>6/1/2026</a:t>
             </a:fld>
             <a:endParaRPr lang="en-US">
               <a:solidFill>
@@ -3984,7 +3984,7 @@
                 </a:solidFill>
               </a:rPr>
               <a:pPr/>
-              <a:t>8/4/2020</a:t>
+              <a:t>6/1/2026</a:t>
             </a:fld>
             <a:endParaRPr lang="en-US">
               <a:solidFill>
@@ -4264,7 +4264,7 @@
                 </a:solidFill>
               </a:rPr>
               <a:pPr/>
-              <a:t>8/4/2020</a:t>
+              <a:t>6/1/2026</a:t>
             </a:fld>
             <a:endParaRPr lang="en-US">
               <a:solidFill>
@@ -4478,7 +4478,7 @@
                 </a:solidFill>
               </a:rPr>
               <a:pPr/>
-              <a:t>8/4/2020</a:t>
+              <a:t>6/1/2026</a:t>
             </a:fld>
             <a:endParaRPr lang="en-US">
               <a:solidFill>
@@ -4758,7 +4758,7 @@
                 </a:solidFill>
               </a:rPr>
               <a:pPr/>
-              <a:t>8/4/2020</a:t>
+              <a:t>6/1/2026</a:t>
             </a:fld>
             <a:endParaRPr lang="en-US">
               <a:solidFill>
@@ -5078,7 +5078,7 @@
                 </a:solidFill>
               </a:rPr>
               <a:pPr/>
-              <a:t>8/4/2020</a:t>
+              <a:t>6/1/2026</a:t>
             </a:fld>
             <a:endParaRPr lang="en-US">
               <a:solidFill>
@@ -5532,7 +5532,7 @@
                 </a:solidFill>
               </a:rPr>
               <a:pPr/>
-              <a:t>8/4/2020</a:t>
+              <a:t>6/1/2026</a:t>
             </a:fld>
             <a:endParaRPr lang="en-US">
               <a:solidFill>
@@ -5684,7 +5684,7 @@
                 </a:solidFill>
               </a:rPr>
               <a:pPr/>
-              <a:t>8/4/2020</a:t>
+              <a:t>6/1/2026</a:t>
             </a:fld>
             <a:endParaRPr lang="en-US">
               <a:solidFill>
@@ -5814,7 +5814,7 @@
                 </a:solidFill>
               </a:rPr>
               <a:pPr/>
-              <a:t>8/4/2020</a:t>
+              <a:t>6/1/2026</a:t>
             </a:fld>
             <a:endParaRPr lang="en-US">
               <a:solidFill>
@@ -6088,7 +6088,7 @@
             <a:fld id="{1D8BD707-D9CF-40AE-B4C6-C98DA3205C09}" type="datetimeFigureOut">
               <a:rPr lang="en-US" smtClean="0"/>
               <a:pPr/>
-              <a:t>8/4/2020</a:t>
+              <a:t>6/1/2026</a:t>
             </a:fld>
             <a:endParaRPr lang="en-US"/>
           </a:p>
@@ -6366,7 +6366,7 @@
                 </a:solidFill>
               </a:rPr>
               <a:pPr/>
-              <a:t>8/4/2020</a:t>
+              <a:t>6/1/2026</a:t>
             </a:fld>
             <a:endParaRPr lang="en-US">
               <a:solidFill>
@@ -6656,7 +6656,7 @@
                 </a:solidFill>
               </a:rPr>
               <a:pPr/>
-              <a:t>8/4/2020</a:t>
+              <a:t>6/1/2026</a:t>
             </a:fld>
             <a:endParaRPr lang="en-US">
               <a:solidFill>
@@ -6859,7 +6859,7 @@
                 </a:solidFill>
               </a:rPr>
               <a:pPr/>
-              <a:t>8/4/2020</a:t>
+              <a:t>6/1/2026</a:t>
             </a:fld>
             <a:endParaRPr lang="en-US">
               <a:solidFill>
@@ -7072,7 +7072,7 @@
                 </a:solidFill>
               </a:rPr>
               <a:pPr/>
-              <a:t>8/4/2020</a:t>
+              <a:t>6/1/2026</a:t>
             </a:fld>
             <a:endParaRPr lang="en-US">
               <a:solidFill>
@@ -7386,7 +7386,7 @@
             <a:fld id="{1D8BD707-D9CF-40AE-B4C6-C98DA3205C09}" type="datetimeFigureOut">
               <a:rPr lang="en-US" smtClean="0"/>
               <a:pPr/>
-              <a:t>8/4/2020</a:t>
+              <a:t>6/1/2026</a:t>
             </a:fld>
             <a:endParaRPr lang="en-US"/>
           </a:p>
@@ -7802,7 +7802,7 @@
             <a:fld id="{1D8BD707-D9CF-40AE-B4C6-C98DA3205C09}" type="datetimeFigureOut">
               <a:rPr lang="en-US" smtClean="0"/>
               <a:pPr/>
-              <a:t>8/4/2020</a:t>
+              <a:t>6/1/2026</a:t>
             </a:fld>
             <a:endParaRPr lang="en-US"/>
           </a:p>
@@ -7916,7 +7916,7 @@
             <a:fld id="{1D8BD707-D9CF-40AE-B4C6-C98DA3205C09}" type="datetimeFigureOut">
               <a:rPr lang="en-US" smtClean="0"/>
               <a:pPr/>
-              <a:t>8/4/2020</a:t>
+              <a:t>6/1/2026</a:t>
             </a:fld>
             <a:endParaRPr lang="en-US"/>
           </a:p>
@@ -8008,7 +8008,7 @@
             <a:fld id="{1D8BD707-D9CF-40AE-B4C6-C98DA3205C09}" type="datetimeFigureOut">
               <a:rPr lang="en-US" smtClean="0"/>
               <a:pPr/>
-              <a:t>8/4/2020</a:t>
+              <a:t>6/1/2026</a:t>
             </a:fld>
             <a:endParaRPr lang="en-US"/>
           </a:p>
@@ -8280,7 +8280,7 @@
             <a:fld id="{1D8BD707-D9CF-40AE-B4C6-C98DA3205C09}" type="datetimeFigureOut">
               <a:rPr lang="en-US" smtClean="0"/>
               <a:pPr/>
-              <a:t>8/4/2020</a:t>
+              <a:t>6/1/2026</a:t>
             </a:fld>
             <a:endParaRPr lang="en-US"/>
           </a:p>
@@ -8529,7 +8529,7 @@
             <a:fld id="{1D8BD707-D9CF-40AE-B4C6-C98DA3205C09}" type="datetimeFigureOut">
               <a:rPr lang="en-US" smtClean="0"/>
               <a:pPr/>
-              <a:t>8/4/2020</a:t>
+              <a:t>6/1/2026</a:t>
             </a:fld>
             <a:endParaRPr lang="en-US"/>
           </a:p>
@@ -8737,7 +8737,7 @@
             <a:fld id="{1D8BD707-D9CF-40AE-B4C6-C98DA3205C09}" type="datetimeFigureOut">
               <a:rPr lang="en-US" smtClean="0"/>
               <a:pPr/>
-              <a:t>8/4/2020</a:t>
+              <a:t>6/1/2026</a:t>
             </a:fld>
             <a:endParaRPr lang="en-US"/>
           </a:p>
@@ -9236,7 +9236,7 @@
                 </a:solidFill>
               </a:rPr>
               <a:pPr defTabSz="913972"/>
-              <a:t>8/4/2020</a:t>
+              <a:t>6/1/2026</a:t>
             </a:fld>
             <a:endParaRPr lang="en-US">
               <a:solidFill>
@@ -9890,7 +9890,7 @@
                 </a:solidFill>
               </a:rPr>
               <a:pPr defTabSz="914079"/>
-              <a:t>8/4/2020</a:t>
+              <a:t>6/1/2026</a:t>
             </a:fld>
             <a:endParaRPr lang="en-US">
               <a:solidFill>
@@ -10686,8 +10686,13 @@
             </a:pPr>
             <a:r>
               <a:rPr lang="en-US" sz="1400" dirty="0"/>
-              <a:t>Primary development organization: NREL</a:t>
-            </a:r>
+              <a:t>Primary development organization</a:t>
+            </a:r>
+            <a:r>
+              <a:rPr lang="en-US" sz="1400"/>
+              <a:t>: NLR</a:t>
+            </a:r>
+            <a:endParaRPr lang="en-US" sz="1400" dirty="0"/>
           </a:p>
           <a:p>
             <a:pPr marL="307682" indent="-307682">
@@ -10752,12 +10757,9 @@
               <a:rPr lang="en-US" sz="1400" dirty="0">
                 <a:hlinkClick r:id="rId2"/>
               </a:rPr>
-              <a:t>Joshua.Eichman@NREL.gov</a:t>
-            </a:r>
-            <a:r>
-              <a:rPr lang="en-US" sz="1400" dirty="0"/>
-              <a:t> </a:t>
-            </a:r>
+              <a:t>omarjose.guerrafernandez@nlr.gov</a:t>
+            </a:r>
+            <a:endParaRPr lang="en-US" sz="1400" dirty="0"/>
           </a:p>
           <a:p>
             <a:pPr marL="307682" indent="-307682">
@@ -10772,7 +10774,7 @@
               <a:rPr lang="en-US" sz="1400" dirty="0">
                 <a:hlinkClick r:id="rId3"/>
               </a:rPr>
-              <a:t>https://github.nrel.gov/jeichman/RODeO</a:t>
+              <a:t>https://github.com/NatLabRockies/RODeO</a:t>
             </a:r>
             <a:r>
               <a:rPr lang="en-US" sz="1400" dirty="0"/>
@@ -12516,4 +12518,10 @@
   <a:objectDefaults/>
   <a:extraClrSchemeLst/>
 </a:theme>
+</file>
+
+<file path=docMetadata/LabelInfo.xml><?xml version="1.0" encoding="utf-8"?>
+<clbl:labelList xmlns:clbl="http://schemas.microsoft.com/office/2020/mipLabelMetadata">
+  <clbl:label id="{95965d95-ecc0-4720-b759-1f33c42ed7da}" enabled="1" method="Standard" siteId="{a0f29d7e-28cd-4f54-8442-7885aee7c080}" contentBits="0" removed="0"/>
+</clbl:labelList>
 </file>
</xml_diff>